<commit_message>
fix: improve slide content extraction and narrative flow
- Clinical scenario: separate narrative/meds/labs into 3 slides
- Introduction: use extract_md_sections for proper paragraph joining
- Classification: clean dedup, merge evidence hierarchy + tool
- extract_paragraphs: fix line-continuation joining for long paragraphs
- Add extract_md_sections helper for ## header splitting

https://claude.ai/code/session_01NHXGTgK1nPZm1TWcGwjxEj
</commit_message>
<xml_diff>
--- a/projects/example-sglt2i-ckd/06_slides/ebm-report.pptx
+++ b/projects/example-sglt2i-ckd/06_slides/ebm-report.pptx
@@ -3596,7 +3596,7 @@
               </a:defRPr>
             </a:pPr>
             <a:r>
-              <a:t>參考文獻</a:t>
+              <a:t>知識缺口與研究動機</a:t>
             </a:r>
           </a:p>
         </p:txBody>
@@ -3634,7 +3634,7 @@
               </a:defRPr>
             </a:pPr>
             <a:r>
-              <a:t>  1. Wen CP, et al. All-cause mortality attributable to chronic kidney disease: a prospective</a:t>
+              <a:t>  鈉-葡萄糖共同轉運蛋白 2 抑制劑（Sodium-Glucose Cotransporter 2 Inhibitors, SGLT2i） 最初開發為降血糖藥物，但近年大型隨機對照試驗（如 CREDENCE、DAPA-CKD、 EMPA-KIDNEY）陸續發現其具有獨立於降糖效果之外的腎臟保護作用。SGLT2i 可能透過 降低腎絲球內壓力（管球回饋機制）、減輕近曲小管氧氣消耗、抑制發炎及纖維化路徑等 多重機轉延緩 CKD 進展。</a:t>
             </a:r>
           </a:p>
           <a:p>
@@ -3649,52 +3649,7 @@
               </a:defRPr>
             </a:pPr>
             <a:r>
-              <a:t>  cohort study based on 462,293 adults in Taiwan. Lancet. 2008;371(9631):2173-2182.</a:t>
-            </a:r>
-          </a:p>
-          <a:p>
-            <a:pPr>
-              <a:spcAft>
-                <a:spcPts val="800"/>
-              </a:spcAft>
-              <a:defRPr sz="1600">
-                <a:solidFill>
-                  <a:srgbClr val="2C3E50"/>
-                </a:solidFill>
-              </a:defRPr>
-            </a:pPr>
-            <a:r>
-              <a:t>  2. USRDS Annual Data Report. 2023.</a:t>
-            </a:r>
-          </a:p>
-          <a:p>
-            <a:pPr>
-              <a:spcAft>
-                <a:spcPts val="800"/>
-              </a:spcAft>
-              <a:defRPr sz="1600">
-                <a:solidFill>
-                  <a:srgbClr val="2C3E50"/>
-                </a:solidFill>
-              </a:defRPr>
-            </a:pPr>
-            <a:r>
-              <a:t>  3. Heerspink HJL, et al. Dapagliflozin in patients with chronic kidney disease. NEJM.</a:t>
-            </a:r>
-          </a:p>
-          <a:p>
-            <a:pPr>
-              <a:spcAft>
-                <a:spcPts val="800"/>
-              </a:spcAft>
-              <a:defRPr sz="1600">
-                <a:solidFill>
-                  <a:srgbClr val="2C3E50"/>
-                </a:solidFill>
-              </a:defRPr>
-            </a:pPr>
-            <a:r>
-              <a:t>  2020;383(15):1436-1446.</a:t>
+              <a:t>  然而，對於 SGLT2i 在已接受 RAAS 阻斷劑之 CKD 合併 T2DM 患者中，能否進一步降低 腎功能惡化、ESRD 及腎臟相關死亡等硬終點，尚需系統性地整合現有證據進行評估。 此為本 EBM 報告之核心臨床問題。</a:t>
             </a:r>
           </a:p>
         </p:txBody>
@@ -4088,7 +4043,7 @@
               </a:defRPr>
             </a:pPr>
             <a:r>
-              <a:t>  治療型 (Therapeutic)</a:t>
+              <a:t>  **治療型 (Therapeutic)**</a:t>
             </a:r>
           </a:p>
           <a:p>
@@ -4103,7 +4058,7 @@
               </a:defRPr>
             </a:pPr>
             <a:r>
-              <a:t>  3. **結論**: I 為藥物治療 + O 為臨床結果改善 → **治療型**</a:t>
+              <a:t>  1. **I 的性質分析**: 介入為 Dapagliflozin 10mg（SGLT2 抑制劑）— 這是一種藥物治療</a:t>
             </a:r>
           </a:p>
           <a:p>
@@ -4118,7 +4073,7 @@
               </a:defRPr>
             </a:pPr>
             <a:r>
-              <a:t>  首選：CASP RCT Checklist</a:t>
+              <a:t>  2. **O 的性質分析**: 結果為腎功能惡化（eGFR 下降、末期腎病、腎臟相關死亡）— 這是臨床結果改善指標</a:t>
             </a:r>
           </a:p>
           <a:p>
@@ -4133,37 +4088,7 @@
               </a:defRPr>
             </a:pPr>
             <a:r>
-              <a:t>  替代：Cochrane RoB 2.0</a:t>
-            </a:r>
-          </a:p>
-          <a:p>
-            <a:pPr>
-              <a:spcAft>
-                <a:spcPts val="800"/>
-              </a:spcAft>
-              <a:defRPr sz="1600">
-                <a:solidFill>
-                  <a:srgbClr val="2C3E50"/>
-                </a:solidFill>
-              </a:defRPr>
-            </a:pPr>
-            <a:r>
-              <a:t>  1. **I 的性質分析**: 介入為 Dapagliflozin 10mg（SGLT2 抑制劑）— 這是一種藥物治療</a:t>
-            </a:r>
-          </a:p>
-          <a:p>
-            <a:pPr>
-              <a:spcAft>
-                <a:spcPts val="800"/>
-              </a:spcAft>
-              <a:defRPr sz="1600">
-                <a:solidFill>
-                  <a:srgbClr val="2C3E50"/>
-                </a:solidFill>
-              </a:defRPr>
-            </a:pPr>
-            <a:r>
-              <a:t>  2. **O 的性質分析**: 結果為腎功能惡化（eGFR 下降、末期腎病、腎臟相關死亡）— 這是臨床結果改善指標</a:t>
+              <a:t>  3. **結論**: I 為藥物治療 + O 為臨床結果改善 → **治療型**</a:t>
             </a:r>
           </a:p>
         </p:txBody>
@@ -4519,7 +4444,7 @@
               </a:defRPr>
             </a:pPr>
             <a:r>
-              <a:t>最佳證據層級</a:t>
+              <a:t>最佳證據層級與評讀工具</a:t>
             </a:r>
           </a:p>
         </p:txBody>
@@ -4557,7 +4482,7 @@
               </a:defRPr>
             </a:pPr>
             <a:r>
-              <a:t>  1. **I 的性質分析**: 介入為 Dapagliflozin 10mg（SGLT2 抑制劑）— 這是一種藥物治療</a:t>
+              <a:t>  1. Systematic Review / Meta-analysis of RCTs</a:t>
             </a:r>
           </a:p>
           <a:p>
@@ -4572,7 +4497,7 @@
               </a:defRPr>
             </a:pPr>
             <a:r>
-              <a:t>  2. **O 的性質分析**: 結果為腎功能惡化（eGFR 下降、末期腎病、腎臟相關死亡）— 這是臨床結果改善指標</a:t>
+              <a:t>  2. Individual RCT</a:t>
             </a:r>
           </a:p>
           <a:p>
@@ -4587,7 +4512,7 @@
               </a:defRPr>
             </a:pPr>
             <a:r>
-              <a:t>  3. **結論**: I 為藥物治療 + O 為臨床結果改善 → **治療型**</a:t>
+              <a:t>  3. Cohort study</a:t>
             </a:r>
           </a:p>
           <a:p>
@@ -4602,7 +4527,7 @@
               </a:defRPr>
             </a:pPr>
             <a:r>
-              <a:t>  1. Systematic Review / Meta-analysis of RCTs</a:t>
+              <a:t>  4. Case-control study</a:t>
             </a:r>
           </a:p>
           <a:p>
@@ -4617,7 +4542,52 @@
               </a:defRPr>
             </a:pPr>
             <a:r>
-              <a:t>  2. Individual RCT</a:t>
+              <a:t>  5. Case series / Case report</a:t>
+            </a:r>
+          </a:p>
+          <a:p>
+            <a:pPr>
+              <a:spcAft>
+                <a:spcPts val="800"/>
+              </a:spcAft>
+              <a:defRPr sz="1600">
+                <a:solidFill>
+                  <a:srgbClr val="2C3E50"/>
+                </a:solidFill>
+              </a:defRPr>
+            </a:pPr>
+            <a:r>
+              <a:t>  ---</a:t>
+            </a:r>
+          </a:p>
+          <a:p>
+            <a:pPr>
+              <a:spcAft>
+                <a:spcPts val="800"/>
+              </a:spcAft>
+              <a:defRPr sz="1600">
+                <a:solidFill>
+                  <a:srgbClr val="2C3E50"/>
+                </a:solidFill>
+              </a:defRPr>
+            </a:pPr>
+            <a:r>
+              <a:t>  首選：CASP RCT Checklist</a:t>
+            </a:r>
+          </a:p>
+          <a:p>
+            <a:pPr>
+              <a:spcAft>
+                <a:spcPts val="800"/>
+              </a:spcAft>
+              <a:defRPr sz="1600">
+                <a:solidFill>
+                  <a:srgbClr val="2C3E50"/>
+                </a:solidFill>
+              </a:defRPr>
+            </a:pPr>
+            <a:r>
+              <a:t>  替代：Cochrane RoB 2.0</a:t>
             </a:r>
           </a:p>
         </p:txBody>
@@ -5179,7 +5149,7 @@
                         </a:defRPr>
                       </a:pPr>
                       <a:r>
-                        <a:t>"Diabetes Mellitus, Type 2"[MeSH] AND "R</a:t>
+                        <a:t>"Diabetes Mellitus, Type 2"[MeSH] AND "Renal Insuf</a:t>
                       </a:r>
                     </a:p>
                   </a:txBody>
@@ -5261,7 +5231,7 @@
                         </a:defRPr>
                       </a:pPr>
                       <a:r>
-                        <a:t>"Sodium-Glucose Transporter 2 Inhibitors</a:t>
+                        <a:t>"Sodium-Glucose Transporter 2 Inhibitors"[MeSH]</a:t>
                       </a:r>
                     </a:p>
                   </a:txBody>
@@ -5433,7 +5403,7 @@
                         </a:defRPr>
                       </a:pPr>
                       <a:r>
-                        <a:t>"Glomerular Filtration Rate"[MeSH], "Kid</a:t>
+                        <a:t>"Glomerular Filtration Rate"[MeSH], "Kidney Failur</a:t>
                       </a:r>
                     </a:p>
                   </a:txBody>
@@ -23740,6 +23710,445 @@
               </a:defRPr>
             </a:pPr>
             <a:r>
+              <a:t>現行治療</a:t>
+            </a:r>
+          </a:p>
+        </p:txBody>
+      </p:sp>
+      <p:sp>
+        <p:nvSpPr>
+          <p:cNvPr id="9" name="TextBox 8"/>
+          <p:cNvSpPr txBox="1"/>
+          <p:nvPr/>
+        </p:nvSpPr>
+        <p:spPr>
+          <a:xfrm>
+            <a:off x="1463040" y="1097280"/>
+            <a:ext cx="7315200" cy="5029200"/>
+          </a:xfrm>
+          <a:prstGeom prst="rect">
+            <a:avLst/>
+          </a:prstGeom>
+          <a:noFill/>
+        </p:spPr>
+        <p:txBody>
+          <a:bodyPr wrap="square">
+            <a:spAutoFit/>
+          </a:bodyPr>
+          <a:lstStyle/>
+          <a:p>
+            <a:pPr>
+              <a:spcAft>
+                <a:spcPts val="800"/>
+              </a:spcAft>
+              <a:defRPr sz="1600">
+                <a:solidFill>
+                  <a:srgbClr val="2C3E50"/>
+                </a:solidFill>
+              </a:defRPr>
+            </a:pPr>
+            <a:r>
+              <a:t>  Metformin 1000mg BID</a:t>
+            </a:r>
+          </a:p>
+          <a:p>
+            <a:pPr>
+              <a:spcAft>
+                <a:spcPts val="800"/>
+              </a:spcAft>
+              <a:defRPr sz="1600">
+                <a:solidFill>
+                  <a:srgbClr val="2C3E50"/>
+                </a:solidFill>
+              </a:defRPr>
+            </a:pPr>
+            <a:r>
+              <a:t>  Glimepiride 2mg QD</a:t>
+            </a:r>
+          </a:p>
+          <a:p>
+            <a:pPr>
+              <a:spcAft>
+                <a:spcPts val="800"/>
+              </a:spcAft>
+              <a:defRPr sz="1600">
+                <a:solidFill>
+                  <a:srgbClr val="2C3E50"/>
+                </a:solidFill>
+              </a:defRPr>
+            </a:pPr>
+            <a:r>
+              <a:t>  Losartan 100mg QD（for hypertension + proteinuria）</a:t>
+            </a:r>
+          </a:p>
+          <a:p>
+            <a:pPr>
+              <a:spcAft>
+                <a:spcPts val="800"/>
+              </a:spcAft>
+              <a:defRPr sz="1600">
+                <a:solidFill>
+                  <a:srgbClr val="2C3E50"/>
+                </a:solidFill>
+              </a:defRPr>
+            </a:pPr>
+            <a:r>
+              <a:t>  Amlodipine 5mg QD</a:t>
+            </a:r>
+          </a:p>
+        </p:txBody>
+      </p:sp>
+    </p:spTree>
+  </p:cSld>
+  <p:clrMapOvr>
+    <a:masterClrMapping/>
+  </p:clrMapOvr>
+</p:sld>
+</file>
+
+<file path=ppt/slides/slide6.xml><?xml version="1.0" encoding="utf-8"?>
+<p:sld xmlns:a="http://schemas.openxmlformats.org/drawingml/2006/main" xmlns:p="http://schemas.openxmlformats.org/presentationml/2006/main" xmlns:r="http://schemas.openxmlformats.org/officeDocument/2006/relationships">
+  <p:cSld>
+    <p:spTree>
+      <p:nvGrpSpPr>
+        <p:cNvPr id="1" name=""/>
+        <p:cNvGrpSpPr/>
+        <p:nvPr/>
+      </p:nvGrpSpPr>
+      <p:grpSpPr/>
+      <p:sp>
+        <p:nvSpPr>
+          <p:cNvPr id="2" name="Rounded Rectangle 1"/>
+          <p:cNvSpPr/>
+          <p:nvPr/>
+        </p:nvSpPr>
+        <p:spPr>
+          <a:xfrm>
+            <a:off x="137160" y="1371600"/>
+            <a:ext cx="1097280" cy="548640"/>
+          </a:xfrm>
+          <a:prstGeom prst="roundRect">
+            <a:avLst/>
+          </a:prstGeom>
+          <a:solidFill>
+            <a:srgbClr val="1B3A5C"/>
+          </a:solidFill>
+          <a:ln>
+            <a:noFill/>
+          </a:ln>
+        </p:spPr>
+        <p:style>
+          <a:lnRef idx="1">
+            <a:schemeClr val="accent1"/>
+          </a:lnRef>
+          <a:fillRef idx="3">
+            <a:schemeClr val="accent1"/>
+          </a:fillRef>
+          <a:effectRef idx="2">
+            <a:schemeClr val="accent1"/>
+          </a:effectRef>
+          <a:fontRef idx="minor">
+            <a:schemeClr val="lt1"/>
+          </a:fontRef>
+        </p:style>
+        <p:txBody>
+          <a:bodyPr rtlCol="0" anchor="ctr" wrap="square"/>
+          <a:lstStyle/>
+          <a:p>
+            <a:pPr algn="ctr">
+              <a:defRPr sz="800" b="1">
+                <a:solidFill>
+                  <a:srgbClr val="FFFFFF"/>
+                </a:solidFill>
+              </a:defRPr>
+            </a:pPr>
+            <a:r>
+              <a:t>問題 ASK</a:t>
+            </a:r>
+          </a:p>
+        </p:txBody>
+      </p:sp>
+      <p:sp>
+        <p:nvSpPr>
+          <p:cNvPr id="3" name="Rounded Rectangle 2"/>
+          <p:cNvSpPr/>
+          <p:nvPr/>
+        </p:nvSpPr>
+        <p:spPr>
+          <a:xfrm>
+            <a:off x="137160" y="1975104"/>
+            <a:ext cx="1097280" cy="548640"/>
+          </a:xfrm>
+          <a:prstGeom prst="roundRect">
+            <a:avLst/>
+          </a:prstGeom>
+          <a:solidFill>
+            <a:srgbClr val="EBF5FB"/>
+          </a:solidFill>
+          <a:ln>
+            <a:noFill/>
+          </a:ln>
+        </p:spPr>
+        <p:style>
+          <a:lnRef idx="1">
+            <a:schemeClr val="accent1"/>
+          </a:lnRef>
+          <a:fillRef idx="3">
+            <a:schemeClr val="accent1"/>
+          </a:fillRef>
+          <a:effectRef idx="2">
+            <a:schemeClr val="accent1"/>
+          </a:effectRef>
+          <a:fontRef idx="minor">
+            <a:schemeClr val="lt1"/>
+          </a:fontRef>
+        </p:style>
+        <p:txBody>
+          <a:bodyPr rtlCol="0" anchor="ctr" wrap="square"/>
+          <a:lstStyle/>
+          <a:p>
+            <a:pPr algn="ctr">
+              <a:defRPr sz="800" b="0">
+                <a:solidFill>
+                  <a:srgbClr val="2C3E50"/>
+                </a:solidFill>
+              </a:defRPr>
+            </a:pPr>
+            <a:r>
+              <a:t>檢索 ACQUIRE</a:t>
+            </a:r>
+          </a:p>
+        </p:txBody>
+      </p:sp>
+      <p:sp>
+        <p:nvSpPr>
+          <p:cNvPr id="4" name="Rounded Rectangle 3"/>
+          <p:cNvSpPr/>
+          <p:nvPr/>
+        </p:nvSpPr>
+        <p:spPr>
+          <a:xfrm>
+            <a:off x="137160" y="2578608"/>
+            <a:ext cx="1097280" cy="548640"/>
+          </a:xfrm>
+          <a:prstGeom prst="roundRect">
+            <a:avLst/>
+          </a:prstGeom>
+          <a:solidFill>
+            <a:srgbClr val="EBF5FB"/>
+          </a:solidFill>
+          <a:ln>
+            <a:noFill/>
+          </a:ln>
+        </p:spPr>
+        <p:style>
+          <a:lnRef idx="1">
+            <a:schemeClr val="accent1"/>
+          </a:lnRef>
+          <a:fillRef idx="3">
+            <a:schemeClr val="accent1"/>
+          </a:fillRef>
+          <a:effectRef idx="2">
+            <a:schemeClr val="accent1"/>
+          </a:effectRef>
+          <a:fontRef idx="minor">
+            <a:schemeClr val="lt1"/>
+          </a:fontRef>
+        </p:style>
+        <p:txBody>
+          <a:bodyPr rtlCol="0" anchor="ctr" wrap="square"/>
+          <a:lstStyle/>
+          <a:p>
+            <a:pPr algn="ctr">
+              <a:defRPr sz="800" b="0">
+                <a:solidFill>
+                  <a:srgbClr val="2C3E50"/>
+                </a:solidFill>
+              </a:defRPr>
+            </a:pPr>
+            <a:r>
+              <a:t>評讀 APPRAISE</a:t>
+            </a:r>
+          </a:p>
+        </p:txBody>
+      </p:sp>
+      <p:sp>
+        <p:nvSpPr>
+          <p:cNvPr id="5" name="Rounded Rectangle 4"/>
+          <p:cNvSpPr/>
+          <p:nvPr/>
+        </p:nvSpPr>
+        <p:spPr>
+          <a:xfrm>
+            <a:off x="137160" y="3182112"/>
+            <a:ext cx="1097280" cy="548640"/>
+          </a:xfrm>
+          <a:prstGeom prst="roundRect">
+            <a:avLst/>
+          </a:prstGeom>
+          <a:solidFill>
+            <a:srgbClr val="EBF5FB"/>
+          </a:solidFill>
+          <a:ln>
+            <a:noFill/>
+          </a:ln>
+        </p:spPr>
+        <p:style>
+          <a:lnRef idx="1">
+            <a:schemeClr val="accent1"/>
+          </a:lnRef>
+          <a:fillRef idx="3">
+            <a:schemeClr val="accent1"/>
+          </a:fillRef>
+          <a:effectRef idx="2">
+            <a:schemeClr val="accent1"/>
+          </a:effectRef>
+          <a:fontRef idx="minor">
+            <a:schemeClr val="lt1"/>
+          </a:fontRef>
+        </p:style>
+        <p:txBody>
+          <a:bodyPr rtlCol="0" anchor="ctr" wrap="square"/>
+          <a:lstStyle/>
+          <a:p>
+            <a:pPr algn="ctr">
+              <a:defRPr sz="800" b="0">
+                <a:solidFill>
+                  <a:srgbClr val="2C3E50"/>
+                </a:solidFill>
+              </a:defRPr>
+            </a:pPr>
+            <a:r>
+              <a:t>應用 APPLY</a:t>
+            </a:r>
+          </a:p>
+        </p:txBody>
+      </p:sp>
+      <p:sp>
+        <p:nvSpPr>
+          <p:cNvPr id="6" name="Rounded Rectangle 5"/>
+          <p:cNvSpPr/>
+          <p:nvPr/>
+        </p:nvSpPr>
+        <p:spPr>
+          <a:xfrm>
+            <a:off x="137160" y="3785616"/>
+            <a:ext cx="1097280" cy="548640"/>
+          </a:xfrm>
+          <a:prstGeom prst="roundRect">
+            <a:avLst/>
+          </a:prstGeom>
+          <a:solidFill>
+            <a:srgbClr val="EBF5FB"/>
+          </a:solidFill>
+          <a:ln>
+            <a:noFill/>
+          </a:ln>
+        </p:spPr>
+        <p:style>
+          <a:lnRef idx="1">
+            <a:schemeClr val="accent1"/>
+          </a:lnRef>
+          <a:fillRef idx="3">
+            <a:schemeClr val="accent1"/>
+          </a:fillRef>
+          <a:effectRef idx="2">
+            <a:schemeClr val="accent1"/>
+          </a:effectRef>
+          <a:fontRef idx="minor">
+            <a:schemeClr val="lt1"/>
+          </a:fontRef>
+        </p:style>
+        <p:txBody>
+          <a:bodyPr rtlCol="0" anchor="ctr" wrap="square"/>
+          <a:lstStyle/>
+          <a:p>
+            <a:pPr algn="ctr">
+              <a:defRPr sz="800" b="0">
+                <a:solidFill>
+                  <a:srgbClr val="2C3E50"/>
+                </a:solidFill>
+              </a:defRPr>
+            </a:pPr>
+            <a:r>
+              <a:t>評估 AUDIT</a:t>
+            </a:r>
+          </a:p>
+        </p:txBody>
+      </p:sp>
+      <p:sp>
+        <p:nvSpPr>
+          <p:cNvPr id="7" name="Rectangle 6"/>
+          <p:cNvSpPr/>
+          <p:nvPr/>
+        </p:nvSpPr>
+        <p:spPr>
+          <a:xfrm>
+            <a:off x="0" y="0"/>
+            <a:ext cx="9144000" cy="822960"/>
+          </a:xfrm>
+          <a:prstGeom prst="rect">
+            <a:avLst/>
+          </a:prstGeom>
+          <a:solidFill>
+            <a:srgbClr val="1B3A5C"/>
+          </a:solidFill>
+          <a:ln>
+            <a:noFill/>
+          </a:ln>
+        </p:spPr>
+        <p:style>
+          <a:lnRef idx="1">
+            <a:schemeClr val="accent1"/>
+          </a:lnRef>
+          <a:fillRef idx="3">
+            <a:schemeClr val="accent1"/>
+          </a:fillRef>
+          <a:effectRef idx="2">
+            <a:schemeClr val="accent1"/>
+          </a:effectRef>
+          <a:fontRef idx="minor">
+            <a:schemeClr val="lt1"/>
+          </a:fontRef>
+        </p:style>
+        <p:txBody>
+          <a:bodyPr rtlCol="0" anchor="ctr"/>
+          <a:lstStyle/>
+          <a:p>
+            <a:pPr algn="ctr"/>
+          </a:p>
+        </p:txBody>
+      </p:sp>
+      <p:sp>
+        <p:nvSpPr>
+          <p:cNvPr id="8" name="TextBox 7"/>
+          <p:cNvSpPr txBox="1"/>
+          <p:nvPr/>
+        </p:nvSpPr>
+        <p:spPr>
+          <a:xfrm>
+            <a:off x="1463040" y="109728"/>
+            <a:ext cx="7315200" cy="640080"/>
+          </a:xfrm>
+          <a:prstGeom prst="rect">
+            <a:avLst/>
+          </a:prstGeom>
+          <a:noFill/>
+        </p:spPr>
+        <p:txBody>
+          <a:bodyPr wrap="none">
+            <a:spAutoFit/>
+          </a:bodyPr>
+          <a:lstStyle/>
+          <a:p>
+            <a:pPr>
+              <a:defRPr sz="2400" b="1">
+                <a:solidFill>
+                  <a:srgbClr val="FFFFFF"/>
+                </a:solidFill>
+              </a:defRPr>
+            </a:pPr>
+            <a:r>
               <a:t>最新檢驗數據</a:t>
             </a:r>
           </a:p>
@@ -24182,445 +24591,6 @@
 </p:sld>
 </file>
 
-<file path=ppt/slides/slide6.xml><?xml version="1.0" encoding="utf-8"?>
-<p:sld xmlns:a="http://schemas.openxmlformats.org/drawingml/2006/main" xmlns:p="http://schemas.openxmlformats.org/presentationml/2006/main" xmlns:r="http://schemas.openxmlformats.org/officeDocument/2006/relationships">
-  <p:cSld>
-    <p:spTree>
-      <p:nvGrpSpPr>
-        <p:cNvPr id="1" name=""/>
-        <p:cNvGrpSpPr/>
-        <p:nvPr/>
-      </p:nvGrpSpPr>
-      <p:grpSpPr/>
-      <p:sp>
-        <p:nvSpPr>
-          <p:cNvPr id="2" name="Rounded Rectangle 1"/>
-          <p:cNvSpPr/>
-          <p:nvPr/>
-        </p:nvSpPr>
-        <p:spPr>
-          <a:xfrm>
-            <a:off x="137160" y="1371600"/>
-            <a:ext cx="1097280" cy="548640"/>
-          </a:xfrm>
-          <a:prstGeom prst="roundRect">
-            <a:avLst/>
-          </a:prstGeom>
-          <a:solidFill>
-            <a:srgbClr val="1B3A5C"/>
-          </a:solidFill>
-          <a:ln>
-            <a:noFill/>
-          </a:ln>
-        </p:spPr>
-        <p:style>
-          <a:lnRef idx="1">
-            <a:schemeClr val="accent1"/>
-          </a:lnRef>
-          <a:fillRef idx="3">
-            <a:schemeClr val="accent1"/>
-          </a:fillRef>
-          <a:effectRef idx="2">
-            <a:schemeClr val="accent1"/>
-          </a:effectRef>
-          <a:fontRef idx="minor">
-            <a:schemeClr val="lt1"/>
-          </a:fontRef>
-        </p:style>
-        <p:txBody>
-          <a:bodyPr rtlCol="0" anchor="ctr" wrap="square"/>
-          <a:lstStyle/>
-          <a:p>
-            <a:pPr algn="ctr">
-              <a:defRPr sz="800" b="1">
-                <a:solidFill>
-                  <a:srgbClr val="FFFFFF"/>
-                </a:solidFill>
-              </a:defRPr>
-            </a:pPr>
-            <a:r>
-              <a:t>問題 ASK</a:t>
-            </a:r>
-          </a:p>
-        </p:txBody>
-      </p:sp>
-      <p:sp>
-        <p:nvSpPr>
-          <p:cNvPr id="3" name="Rounded Rectangle 2"/>
-          <p:cNvSpPr/>
-          <p:nvPr/>
-        </p:nvSpPr>
-        <p:spPr>
-          <a:xfrm>
-            <a:off x="137160" y="1975104"/>
-            <a:ext cx="1097280" cy="548640"/>
-          </a:xfrm>
-          <a:prstGeom prst="roundRect">
-            <a:avLst/>
-          </a:prstGeom>
-          <a:solidFill>
-            <a:srgbClr val="EBF5FB"/>
-          </a:solidFill>
-          <a:ln>
-            <a:noFill/>
-          </a:ln>
-        </p:spPr>
-        <p:style>
-          <a:lnRef idx="1">
-            <a:schemeClr val="accent1"/>
-          </a:lnRef>
-          <a:fillRef idx="3">
-            <a:schemeClr val="accent1"/>
-          </a:fillRef>
-          <a:effectRef idx="2">
-            <a:schemeClr val="accent1"/>
-          </a:effectRef>
-          <a:fontRef idx="minor">
-            <a:schemeClr val="lt1"/>
-          </a:fontRef>
-        </p:style>
-        <p:txBody>
-          <a:bodyPr rtlCol="0" anchor="ctr" wrap="square"/>
-          <a:lstStyle/>
-          <a:p>
-            <a:pPr algn="ctr">
-              <a:defRPr sz="800" b="0">
-                <a:solidFill>
-                  <a:srgbClr val="2C3E50"/>
-                </a:solidFill>
-              </a:defRPr>
-            </a:pPr>
-            <a:r>
-              <a:t>檢索 ACQUIRE</a:t>
-            </a:r>
-          </a:p>
-        </p:txBody>
-      </p:sp>
-      <p:sp>
-        <p:nvSpPr>
-          <p:cNvPr id="4" name="Rounded Rectangle 3"/>
-          <p:cNvSpPr/>
-          <p:nvPr/>
-        </p:nvSpPr>
-        <p:spPr>
-          <a:xfrm>
-            <a:off x="137160" y="2578608"/>
-            <a:ext cx="1097280" cy="548640"/>
-          </a:xfrm>
-          <a:prstGeom prst="roundRect">
-            <a:avLst/>
-          </a:prstGeom>
-          <a:solidFill>
-            <a:srgbClr val="EBF5FB"/>
-          </a:solidFill>
-          <a:ln>
-            <a:noFill/>
-          </a:ln>
-        </p:spPr>
-        <p:style>
-          <a:lnRef idx="1">
-            <a:schemeClr val="accent1"/>
-          </a:lnRef>
-          <a:fillRef idx="3">
-            <a:schemeClr val="accent1"/>
-          </a:fillRef>
-          <a:effectRef idx="2">
-            <a:schemeClr val="accent1"/>
-          </a:effectRef>
-          <a:fontRef idx="minor">
-            <a:schemeClr val="lt1"/>
-          </a:fontRef>
-        </p:style>
-        <p:txBody>
-          <a:bodyPr rtlCol="0" anchor="ctr" wrap="square"/>
-          <a:lstStyle/>
-          <a:p>
-            <a:pPr algn="ctr">
-              <a:defRPr sz="800" b="0">
-                <a:solidFill>
-                  <a:srgbClr val="2C3E50"/>
-                </a:solidFill>
-              </a:defRPr>
-            </a:pPr>
-            <a:r>
-              <a:t>評讀 APPRAISE</a:t>
-            </a:r>
-          </a:p>
-        </p:txBody>
-      </p:sp>
-      <p:sp>
-        <p:nvSpPr>
-          <p:cNvPr id="5" name="Rounded Rectangle 4"/>
-          <p:cNvSpPr/>
-          <p:nvPr/>
-        </p:nvSpPr>
-        <p:spPr>
-          <a:xfrm>
-            <a:off x="137160" y="3182112"/>
-            <a:ext cx="1097280" cy="548640"/>
-          </a:xfrm>
-          <a:prstGeom prst="roundRect">
-            <a:avLst/>
-          </a:prstGeom>
-          <a:solidFill>
-            <a:srgbClr val="EBF5FB"/>
-          </a:solidFill>
-          <a:ln>
-            <a:noFill/>
-          </a:ln>
-        </p:spPr>
-        <p:style>
-          <a:lnRef idx="1">
-            <a:schemeClr val="accent1"/>
-          </a:lnRef>
-          <a:fillRef idx="3">
-            <a:schemeClr val="accent1"/>
-          </a:fillRef>
-          <a:effectRef idx="2">
-            <a:schemeClr val="accent1"/>
-          </a:effectRef>
-          <a:fontRef idx="minor">
-            <a:schemeClr val="lt1"/>
-          </a:fontRef>
-        </p:style>
-        <p:txBody>
-          <a:bodyPr rtlCol="0" anchor="ctr" wrap="square"/>
-          <a:lstStyle/>
-          <a:p>
-            <a:pPr algn="ctr">
-              <a:defRPr sz="800" b="0">
-                <a:solidFill>
-                  <a:srgbClr val="2C3E50"/>
-                </a:solidFill>
-              </a:defRPr>
-            </a:pPr>
-            <a:r>
-              <a:t>應用 APPLY</a:t>
-            </a:r>
-          </a:p>
-        </p:txBody>
-      </p:sp>
-      <p:sp>
-        <p:nvSpPr>
-          <p:cNvPr id="6" name="Rounded Rectangle 5"/>
-          <p:cNvSpPr/>
-          <p:nvPr/>
-        </p:nvSpPr>
-        <p:spPr>
-          <a:xfrm>
-            <a:off x="137160" y="3785616"/>
-            <a:ext cx="1097280" cy="548640"/>
-          </a:xfrm>
-          <a:prstGeom prst="roundRect">
-            <a:avLst/>
-          </a:prstGeom>
-          <a:solidFill>
-            <a:srgbClr val="EBF5FB"/>
-          </a:solidFill>
-          <a:ln>
-            <a:noFill/>
-          </a:ln>
-        </p:spPr>
-        <p:style>
-          <a:lnRef idx="1">
-            <a:schemeClr val="accent1"/>
-          </a:lnRef>
-          <a:fillRef idx="3">
-            <a:schemeClr val="accent1"/>
-          </a:fillRef>
-          <a:effectRef idx="2">
-            <a:schemeClr val="accent1"/>
-          </a:effectRef>
-          <a:fontRef idx="minor">
-            <a:schemeClr val="lt1"/>
-          </a:fontRef>
-        </p:style>
-        <p:txBody>
-          <a:bodyPr rtlCol="0" anchor="ctr" wrap="square"/>
-          <a:lstStyle/>
-          <a:p>
-            <a:pPr algn="ctr">
-              <a:defRPr sz="800" b="0">
-                <a:solidFill>
-                  <a:srgbClr val="2C3E50"/>
-                </a:solidFill>
-              </a:defRPr>
-            </a:pPr>
-            <a:r>
-              <a:t>評估 AUDIT</a:t>
-            </a:r>
-          </a:p>
-        </p:txBody>
-      </p:sp>
-      <p:sp>
-        <p:nvSpPr>
-          <p:cNvPr id="7" name="Rectangle 6"/>
-          <p:cNvSpPr/>
-          <p:nvPr/>
-        </p:nvSpPr>
-        <p:spPr>
-          <a:xfrm>
-            <a:off x="0" y="0"/>
-            <a:ext cx="9144000" cy="822960"/>
-          </a:xfrm>
-          <a:prstGeom prst="rect">
-            <a:avLst/>
-          </a:prstGeom>
-          <a:solidFill>
-            <a:srgbClr val="1B3A5C"/>
-          </a:solidFill>
-          <a:ln>
-            <a:noFill/>
-          </a:ln>
-        </p:spPr>
-        <p:style>
-          <a:lnRef idx="1">
-            <a:schemeClr val="accent1"/>
-          </a:lnRef>
-          <a:fillRef idx="3">
-            <a:schemeClr val="accent1"/>
-          </a:fillRef>
-          <a:effectRef idx="2">
-            <a:schemeClr val="accent1"/>
-          </a:effectRef>
-          <a:fontRef idx="minor">
-            <a:schemeClr val="lt1"/>
-          </a:fontRef>
-        </p:style>
-        <p:txBody>
-          <a:bodyPr rtlCol="0" anchor="ctr"/>
-          <a:lstStyle/>
-          <a:p>
-            <a:pPr algn="ctr"/>
-          </a:p>
-        </p:txBody>
-      </p:sp>
-      <p:sp>
-        <p:nvSpPr>
-          <p:cNvPr id="8" name="TextBox 7"/>
-          <p:cNvSpPr txBox="1"/>
-          <p:nvPr/>
-        </p:nvSpPr>
-        <p:spPr>
-          <a:xfrm>
-            <a:off x="1463040" y="109728"/>
-            <a:ext cx="7315200" cy="640080"/>
-          </a:xfrm>
-          <a:prstGeom prst="rect">
-            <a:avLst/>
-          </a:prstGeom>
-          <a:noFill/>
-        </p:spPr>
-        <p:txBody>
-          <a:bodyPr wrap="none">
-            <a:spAutoFit/>
-          </a:bodyPr>
-          <a:lstStyle/>
-          <a:p>
-            <a:pPr>
-              <a:defRPr sz="2400" b="1">
-                <a:solidFill>
-                  <a:srgbClr val="FFFFFF"/>
-                </a:solidFill>
-              </a:defRPr>
-            </a:pPr>
-            <a:r>
-              <a:t>慢性腎臟病流行病學</a:t>
-            </a:r>
-          </a:p>
-        </p:txBody>
-      </p:sp>
-      <p:sp>
-        <p:nvSpPr>
-          <p:cNvPr id="9" name="TextBox 8"/>
-          <p:cNvSpPr txBox="1"/>
-          <p:nvPr/>
-        </p:nvSpPr>
-        <p:spPr>
-          <a:xfrm>
-            <a:off x="1463040" y="1097280"/>
-            <a:ext cx="7315200" cy="5029200"/>
-          </a:xfrm>
-          <a:prstGeom prst="rect">
-            <a:avLst/>
-          </a:prstGeom>
-          <a:noFill/>
-        </p:spPr>
-        <p:txBody>
-          <a:bodyPr wrap="square">
-            <a:spAutoFit/>
-          </a:bodyPr>
-          <a:lstStyle/>
-          <a:p>
-            <a:pPr>
-              <a:spcAft>
-                <a:spcPts val="800"/>
-              </a:spcAft>
-              <a:defRPr sz="1600">
-                <a:solidFill>
-                  <a:srgbClr val="2C3E50"/>
-                </a:solidFill>
-              </a:defRPr>
-            </a:pPr>
-            <a:r>
-              <a:t>  慢性腎臟病（Chronic Kidney Disease, CKD）為全球重大公共衛生議題。根據台灣腎臟</a:t>
-            </a:r>
-          </a:p>
-          <a:p>
-            <a:pPr>
-              <a:spcAft>
-                <a:spcPts val="800"/>
-              </a:spcAft>
-              <a:defRPr sz="1600">
-                <a:solidFill>
-                  <a:srgbClr val="2C3E50"/>
-                </a:solidFill>
-              </a:defRPr>
-            </a:pPr>
-            <a:r>
-              <a:t>  醫學會統計，台灣成人 CKD 盛行率約為 12%，推估約有 200 萬人以上受影響。CKD 不僅</a:t>
-            </a:r>
-          </a:p>
-          <a:p>
-            <a:pPr>
-              <a:spcAft>
-                <a:spcPts val="800"/>
-              </a:spcAft>
-              <a:defRPr sz="1600">
-                <a:solidFill>
-                  <a:srgbClr val="2C3E50"/>
-                </a:solidFill>
-              </a:defRPr>
-            </a:pPr>
-            <a:r>
-              <a:t>  增加心血管事件風險，晚期更可能進展至末期腎臟病（End-Stage Renal Disease, ESRD），</a:t>
-            </a:r>
-          </a:p>
-          <a:p>
-            <a:pPr>
-              <a:spcAft>
-                <a:spcPts val="800"/>
-              </a:spcAft>
-              <a:defRPr sz="1600">
-                <a:solidFill>
-                  <a:srgbClr val="2C3E50"/>
-                </a:solidFill>
-              </a:defRPr>
-            </a:pPr>
-            <a:r>
-              <a:t>  需接受透析或腎臟移植治療。台灣長期以來透析盛行率居全球前列，對醫療資源造成沉重</a:t>
-            </a:r>
-          </a:p>
-        </p:txBody>
-      </p:sp>
-    </p:spTree>
-  </p:cSld>
-  <p:clrMapOvr>
-    <a:masterClrMapping/>
-  </p:clrMapOvr>
-</p:sld>
-</file>
-
 <file path=ppt/slides/slide7.xml><?xml version="1.0" encoding="utf-8"?>
 <p:sld xmlns:a="http://schemas.openxmlformats.org/drawingml/2006/main" xmlns:p="http://schemas.openxmlformats.org/presentationml/2006/main" xmlns:r="http://schemas.openxmlformats.org/officeDocument/2006/relationships">
   <p:cSld>
@@ -24964,7 +24934,7 @@
               </a:defRPr>
             </a:pPr>
             <a:r>
-              <a:t>第二型糖尿病與慢性腎臟病之關聯</a:t>
+              <a:t>慢性腎臟病流行病學</a:t>
             </a:r>
           </a:p>
         </p:txBody>
@@ -25002,67 +24972,7 @@
               </a:defRPr>
             </a:pPr>
             <a:r>
-              <a:t>  第二型糖尿病（Type 2 Diabetes Mellitus, T2DM）為 CKD 最主要的致病因子之一。糖尿</a:t>
-            </a:r>
-          </a:p>
-          <a:p>
-            <a:pPr>
-              <a:spcAft>
-                <a:spcPts val="800"/>
-              </a:spcAft>
-              <a:defRPr sz="1600">
-                <a:solidFill>
-                  <a:srgbClr val="2C3E50"/>
-                </a:solidFill>
-              </a:defRPr>
-            </a:pPr>
-            <a:r>
-              <a:t>  病腎病變（Diabetic Nephropathy）為台灣新進入透析病患的首要原因，佔所有新透析個案</a:t>
-            </a:r>
-          </a:p>
-          <a:p>
-            <a:pPr>
-              <a:spcAft>
-                <a:spcPts val="800"/>
-              </a:spcAft>
-              <a:defRPr sz="1600">
-                <a:solidFill>
-                  <a:srgbClr val="2C3E50"/>
-                </a:solidFill>
-              </a:defRPr>
-            </a:pPr>
-            <a:r>
-              <a:t>  約 40-45%。長期高血糖狀態導致腎絲球高過濾、基底膜增厚、系膜基質堆積，最終引起</a:t>
-            </a:r>
-          </a:p>
-          <a:p>
-            <a:pPr>
-              <a:spcAft>
-                <a:spcPts val="800"/>
-              </a:spcAft>
-              <a:defRPr sz="1600">
-                <a:solidFill>
-                  <a:srgbClr val="2C3E50"/>
-                </a:solidFill>
-              </a:defRPr>
-            </a:pPr>
-            <a:r>
-              <a:t>  腎絲球硬化及腎小管間質纖維化。隨著病程進展，蛋白尿增加、腎絲球過濾率（eGFR）</a:t>
-            </a:r>
-          </a:p>
-          <a:p>
-            <a:pPr>
-              <a:spcAft>
-                <a:spcPts val="800"/>
-              </a:spcAft>
-              <a:defRPr sz="1600">
-                <a:solidFill>
-                  <a:srgbClr val="2C3E50"/>
-                </a:solidFill>
-              </a:defRPr>
-            </a:pPr>
-            <a:r>
-              <a:t>  逐漸下降，部分患者在 10-20 年內進展至 ESRD。</a:t>
+              <a:t>  慢性腎臟病（Chronic Kidney Disease, CKD）為全球重大公共衛生議題。根據台灣腎臟 醫學會統計，台灣成人 CKD 盛行率約為 12%，推估約有 200 萬人以上受影響。CKD 不僅 增加心血管事件風險，晚期更可能進展至末期腎臟病（End-Stage Renal Disease, ESRD）， 需接受透析或腎臟移植治療。台灣長期以來透析盛行率居全球前列，對醫療資源造成沉重 負擔。</a:t>
             </a:r>
           </a:p>
         </p:txBody>
@@ -25418,7 +25328,7 @@
               </a:defRPr>
             </a:pPr>
             <a:r>
-              <a:t>目前治療策略</a:t>
+              <a:t>第二型糖尿病與慢性腎臟病之關聯</a:t>
             </a:r>
           </a:p>
         </p:txBody>
@@ -25456,67 +25366,7 @@
               </a:defRPr>
             </a:pPr>
             <a:r>
-              <a:t>  現行 CKD 合併 T2DM 患者的腎臟保護治療以腎素-血管張力素-醛固酮系統</a:t>
-            </a:r>
-          </a:p>
-          <a:p>
-            <a:pPr>
-              <a:spcAft>
-                <a:spcPts val="800"/>
-              </a:spcAft>
-              <a:defRPr sz="1600">
-                <a:solidFill>
-                  <a:srgbClr val="2C3E50"/>
-                </a:solidFill>
-              </a:defRPr>
-            </a:pPr>
-            <a:r>
-              <a:t>  （Renin-Angiotensin-Aldosterone System, RAAS）阻斷劑為基石，包含血管張力素轉化酶</a:t>
-            </a:r>
-          </a:p>
-          <a:p>
-            <a:pPr>
-              <a:spcAft>
-                <a:spcPts val="800"/>
-              </a:spcAft>
-              <a:defRPr sz="1600">
-                <a:solidFill>
-                  <a:srgbClr val="2C3E50"/>
-                </a:solidFill>
-              </a:defRPr>
-            </a:pPr>
-            <a:r>
-              <a:t>  抑制劑（ACEi）及血管張力素受體阻斷劑（ARB）。此類藥物已被證實可降低蛋白尿、</a:t>
-            </a:r>
-          </a:p>
-          <a:p>
-            <a:pPr>
-              <a:spcAft>
-                <a:spcPts val="800"/>
-              </a:spcAft>
-              <a:defRPr sz="1600">
-                <a:solidFill>
-                  <a:srgbClr val="2C3E50"/>
-                </a:solidFill>
-              </a:defRPr>
-            </a:pPr>
-            <a:r>
-              <a:t>  延緩 eGFR 下降速率，為國際指引建議之一線治療。然而，即使在最佳化 RAAS 阻斷劑</a:t>
-            </a:r>
-          </a:p>
-          <a:p>
-            <a:pPr>
-              <a:spcAft>
-                <a:spcPts val="800"/>
-              </a:spcAft>
-              <a:defRPr sz="1600">
-                <a:solidFill>
-                  <a:srgbClr val="2C3E50"/>
-                </a:solidFill>
-              </a:defRPr>
-            </a:pPr>
-            <a:r>
-              <a:t>  治療下，仍有相當比例的患者持續出現腎功能惡化，顯示目前治療仍有未被滿足的臨床</a:t>
+              <a:t>  第二型糖尿病（Type 2 Diabetes Mellitus, T2DM）為 CKD 最主要的致病因子之一。糖尿 病腎病變（Diabetic Nephropathy）為台灣新進入透析病患的首要原因，佔所有新透析個案 約 40-45%。長期高血糖狀態導致腎絲球高過濾、基底膜增厚、系膜基質堆積，最終引起 腎絲球硬化及腎小管間質纖維化。隨著病程進展，蛋白尿增加、腎絲球過濾率（eGFR） 逐漸下降，部分患者在 10-20 年內進展至 ESRD。</a:t>
             </a:r>
           </a:p>
         </p:txBody>
@@ -25872,7 +25722,7 @@
               </a:defRPr>
             </a:pPr>
             <a:r>
-              <a:t>知識缺口與研究動機</a:t>
+              <a:t>目前治療策略</a:t>
             </a:r>
           </a:p>
         </p:txBody>
@@ -25910,67 +25760,7 @@
               </a:defRPr>
             </a:pPr>
             <a:r>
-              <a:t>  鈉-葡萄糖共同轉運蛋白 2 抑制劑（Sodium-Glucose Cotransporter 2 Inhibitors, SGLT2i）</a:t>
-            </a:r>
-          </a:p>
-          <a:p>
-            <a:pPr>
-              <a:spcAft>
-                <a:spcPts val="800"/>
-              </a:spcAft>
-              <a:defRPr sz="1600">
-                <a:solidFill>
-                  <a:srgbClr val="2C3E50"/>
-                </a:solidFill>
-              </a:defRPr>
-            </a:pPr>
-            <a:r>
-              <a:t>  最初開發為降血糖藥物，但近年大型隨機對照試驗（如 CREDENCE、DAPA-CKD、</a:t>
-            </a:r>
-          </a:p>
-          <a:p>
-            <a:pPr>
-              <a:spcAft>
-                <a:spcPts val="800"/>
-              </a:spcAft>
-              <a:defRPr sz="1600">
-                <a:solidFill>
-                  <a:srgbClr val="2C3E50"/>
-                </a:solidFill>
-              </a:defRPr>
-            </a:pPr>
-            <a:r>
-              <a:t>  EMPA-KIDNEY）陸續發現其具有獨立於降糖效果之外的腎臟保護作用。SGLT2i 可能透過</a:t>
-            </a:r>
-          </a:p>
-          <a:p>
-            <a:pPr>
-              <a:spcAft>
-                <a:spcPts val="800"/>
-              </a:spcAft>
-              <a:defRPr sz="1600">
-                <a:solidFill>
-                  <a:srgbClr val="2C3E50"/>
-                </a:solidFill>
-              </a:defRPr>
-            </a:pPr>
-            <a:r>
-              <a:t>  降低腎絲球內壓力（管球回饋機制）、減輕近曲小管氧氣消耗、抑制發炎及纖維化路徑等</a:t>
-            </a:r>
-          </a:p>
-          <a:p>
-            <a:pPr>
-              <a:spcAft>
-                <a:spcPts val="800"/>
-              </a:spcAft>
-              <a:defRPr sz="1600">
-                <a:solidFill>
-                  <a:srgbClr val="2C3E50"/>
-                </a:solidFill>
-              </a:defRPr>
-            </a:pPr>
-            <a:r>
-              <a:t>  然而，對於 SGLT2i 在已接受 RAAS 阻斷劑之 CKD 合併 T2DM 患者中，能否進一步降低</a:t>
+              <a:t>  現行 CKD 合併 T2DM 患者的腎臟保護治療以腎素-血管張力素-醛固酮系統 （Renin-Angiotensin-Aldosterone System, RAAS）阻斷劑為基石，包含血管張力素轉化酶 抑制劑（ACEi）及血管張力素受體阻斷劑（ARB）。此類藥物已被證實可降低蛋白尿、 延緩 eGFR 下降速率，為國際指引建議之一線治療。然而，即使在最佳化 RAAS 阻斷劑 治療下，仍有相當比例的患者持續出現腎功能惡化，顯示目前治療仍有未被滿足的臨床 需求（unmet clinical need）。</a:t>
             </a:r>
           </a:p>
         </p:txBody>

</xml_diff>